<commit_message>
Update strategy doc and slides with verified coaching data and website alignment
- Landscape doc: corrected women-in-coaching figures with citation, new
  Section 8 (website and go-to-market alignment), refreshed 90-day plan
- Slides: corrected stats panel and source line; regenerated pptx

Co-Authored-By: Claude Opus 5.5 <noreply@anthropic.com>
</commit_message>
<xml_diff>
--- a/_strategy/dexter-comp-slides.pptx
+++ b/_strategy/dexter-comp-slides.pptx
@@ -503,7 +503,7 @@
           <a:p>
             <a:r>
               <a:rPr lang="en-US" dirty="0"/>
-              <a:t>Big agencies fight over Power-5 head coaches. Boutiques like BDS stop at women's basketball. Nobody serves women coaches and assistants across all sports at mid-major and below. That is Dexter's lane.</a:t>
+              <a:t>Women are nearly two-thirds of full-time assistant coaches but only 46% of coaches for women's teams and 6 in 100 for men's teams (Collective Think Tank, 2026). Big agencies fight over Power-5 head coaches. Boutiques like BDS stop at women's basketball. Nobody serves women coaches and assistants across all sports at mid-major and below. That is Dexter's lane.</a:t>
             </a:r>
             <a:endParaRPr lang="en-US" dirty="0"/>
           </a:p>
@@ -2074,7 +2074,7 @@
                 <a:ea typeface="Georgia" pitchFamily="34" charset="-122"/>
                 <a:cs typeface="Georgia" pitchFamily="34" charset="-120"/>
               </a:rPr>
-              <a:t>41%</a:t>
+              <a:t>~2/3</a:t>
             </a:r>
             <a:endParaRPr lang="en-US" sz="2200" dirty="0"/>
           </a:p>
@@ -2110,7 +2110,7 @@
                   <a:srgbClr val="1F2937"/>
                 </a:solidFill>
               </a:rPr>
-              <a:t>of women's college teams are led by women; ~7% by women of color</a:t>
+              <a:t>of full-time assistant coaches are women: the pipeline we serve*</a:t>
             </a:r>
             <a:endParaRPr lang="en-US" sz="950" dirty="0"/>
           </a:p>
@@ -2172,7 +2172,7 @@
                 <a:ea typeface="Georgia" pitchFamily="34" charset="-122"/>
                 <a:cs typeface="Georgia" pitchFamily="34" charset="-120"/>
               </a:rPr>
-              <a:t>~2/3</a:t>
+              <a:t>46%</a:t>
             </a:r>
             <a:endParaRPr lang="en-US" sz="2200" dirty="0"/>
           </a:p>
@@ -2208,7 +2208,7 @@
                   <a:srgbClr val="1F2937"/>
                 </a:solidFill>
               </a:rPr>
-              <a:t>of full-time assistant coaches are women: the pipeline we serve</a:t>
+              <a:t>of coaches for women's college teams are women (2024); just 6 in 100 for men's teams*</a:t>
             </a:r>
             <a:endParaRPr lang="en-US" sz="950" dirty="0"/>
           </a:p>
@@ -2342,7 +2342,7 @@
                   <a:srgbClr val="6B7280"/>
                 </a:solidFill>
               </a:rPr>
-              <a:t>Positioning is illustrative. Sources: NCAA, WeCOACH, Sportico, Pollstar.</a:t>
+              <a:t>Positioning is illustrative. *The Collective Think Tank, Women in NCAA Intercollegiate Athletics: The Legacy Revisited (2026), via WIA Report. CAA: Sportico, Pollstar.</a:t>
             </a:r>
             <a:endParaRPr lang="en-US" sz="700" dirty="0"/>
           </a:p>

</xml_diff>

<commit_message>
Add sourced women-of-color coaching stat (Tucker Center 2025-26) to site, strategy doc, and slides
Co-Authored-By: Claude Opus 5.5 <noreply@anthropic.com>
</commit_message>
<xml_diff>
--- a/_strategy/dexter-comp-slides.pptx
+++ b/_strategy/dexter-comp-slides.pptx
@@ -503,7 +503,7 @@
           <a:p>
             <a:r>
               <a:rPr lang="en-US" dirty="0"/>
-              <a:t>Women are nearly two-thirds of full-time assistant coaches but only 46% of coaches for women's teams and 6 in 100 for men's teams (Collective Think Tank, 2026). Big agencies fight over Power-5 head coaches. Boutiques like BDS stop at women's basketball. Nobody serves women coaches and assistants across all sports at mid-major and below. That is Dexter's lane.</a:t>
+              <a:t>Women are nearly two-thirds of full-time assistant coaches but only 46% of coaches for women's teams and 6 in 100 for men's teams (Collective Think Tank, 2026). Women of color hold 7.3% of head-coach jobs on women's teams at 94 D-I schools, and 44% of those schools have none (Tucker Center, 2025-26). Big agencies fight over Power-5 head coaches. Boutiques like BDS stop at women's basketball. Nobody serves women coaches and assistants across all sports at mid-major and below. That is Dexter's lane.</a:t>
             </a:r>
             <a:endParaRPr lang="en-US" dirty="0"/>
           </a:p>
@@ -2172,7 +2172,7 @@
                 <a:ea typeface="Georgia" pitchFamily="34" charset="-122"/>
                 <a:cs typeface="Georgia" pitchFamily="34" charset="-120"/>
               </a:rPr>
-              <a:t>46%</a:t>
+              <a:t>7.3%</a:t>
             </a:r>
             <a:endParaRPr lang="en-US" sz="2200" dirty="0"/>
           </a:p>
@@ -2208,7 +2208,7 @@
                   <a:srgbClr val="1F2937"/>
                 </a:solidFill>
               </a:rPr>
-              <a:t>of coaches for women's college teams are women (2024); just 6 in 100 for men's teams*</a:t>
+              <a:t>of head coaches of women's teams at 94 D-I schools are women of color; 44% of those schools have none**</a:t>
             </a:r>
             <a:endParaRPr lang="en-US" sz="950" dirty="0"/>
           </a:p>
@@ -2342,7 +2342,7 @@
                   <a:srgbClr val="6B7280"/>
                 </a:solidFill>
               </a:rPr>
-              <a:t>Positioning is illustrative. *The Collective Think Tank, Women in NCAA Intercollegiate Athletics: The Legacy Revisited (2026), via WIA Report. CAA: Sportico, Pollstar.</a:t>
+              <a:t>Positioning is illustrative. *The Collective Think Tank (2026). **Tucker Center &amp; WeCOACH, Women in College Coaching Report Card 2025–26. Both via WIA Report. CAA: Sportico, Pollstar.</a:t>
             </a:r>
             <a:endParaRPr lang="en-US" sz="700" dirty="0"/>
           </a:p>

</xml_diff>